<commit_message>
Reframe the independence limitation to match what the paper claims
The previous wording ("we built it and we evaluated it") read as though
the researchers rated their own system. They did not: every rating came
from an external respondent -- 46 job seekers, 11 HR personnel and 3 IT
experts. The manuscript's actual claim is narrower: respondents rated a
system built by the people who wrote the instruments and recruited them,
which is a favourable-response bias, not self-rating.

Reworded across all four reviewers and both decks to lead with the
external respondents and concede only what the paper concedes.

Co-Authored-By: Claude Opus 5 <noreply@anthropic.com>
Claude-Session: https://claude.ai/code/session_01KJCBhwXyDj1kaiQWF9G7ZP
</commit_message>
<xml_diff>
--- a/05_Website_Angular/docs/Linaw-PH-Defence-Presentation.pptx
+++ b/05_Website_Angular/docs/Linaw-PH-Defence-Presentation.pptx
@@ -1234,7 +1234,7 @@
           </a:p>
           <a:p>
             <a:r>
-              <a:t>"On validity: our adviser reviewed every item against the research question or ISO characteristic it was written for, following Lawshe, and we pilot-tested with three to five people outside the sample. On reliability: Cronbach's alpha per characteristic, reported as it came out. Two of our values fall below point seven and we report them as they stand, together with the items that pulled them down — dropping an item because it lowered alpha, without saying so, would make the reported figure describe an instrument that was never administered. And on the threat we cannot remove: we built this system and we are also evaluating it. Four measures exist specifically against that, and they limit it. They do not eliminate it, and we say so."</a:t>
+              <a:t>"On validity: our adviser reviewed every item against the research question or ISO characteristic it was written for, following Lawshe, and we pilot-tested with three to five people outside the sample. On reliability: Cronbach's alpha per characteristic, reported as it came out. Two of our values fall below point seven and we report them as they stand, together with the items that pulled them down — dropping an item because it lowered alpha, without saying so, would make the reported figure describe an instrument that was never administered. And on the one threat we can only reduce: every rating came from an external respondent — none of us rated our own system — but we wrote the instruments and recruited the people who did, and they knew whose system it was. Four measures exist specifically against that, and they limit it. They do not eliminate it, and we say so."</a:t>
             </a:r>
           </a:p>
           <a:p/>
@@ -1245,7 +1245,7 @@
           </a:p>
           <a:p>
             <a:r>
-              <a:t>Conceding the self-evaluation bias before being asked is worth more than any defence of it.</a:t>
+              <a:t>Conceding the independence limitation before being asked is worth more than any defence of it — but concede the right thing. You did not rate your own system; outsiders did.</a:t>
             </a:r>
           </a:p>
           <a:p/>
@@ -1278,7 +1278,7 @@
           </a:p>
           <a:p>
             <a:r>
-              <a:t>"You should treat them with some caution, and we say so in the paper rather than waiting to be asked. Four measures exist against it: responses are confidential and never reported identifiably, no researcher was present while anyone answered, the invitation states explicitly that critical accounts are as useful as favourable ones, and the interpretation scale was published before we collected any data so we could not choose the bands to suit the result. The partial evidence that they worked: neither user group reached the excellent band on any characteristic."</a:t>
+              <a:t>"To be precise about what we are conceding: none of us rated the system. Every rating came from an external respondent — forty-six job seekers, eleven HR personnel of the partner company, and three IT experts. What we do concede is that we wrote the instruments and recruited those respondents, and they knew whose system they were rating, which is a documented source of favourable response. Four measures exist against it: responses are confidential and never reported identifiably, no researcher was present while anyone answered, the invitation states explicitly that critical accounts are as useful as favourable ones, and the interpretation scale was published before we collected any data so we could not choose the bands to suit the result. The partial evidence that they worked: neither user group reached the excellent band on any characteristic."</a:t>
             </a:r>
           </a:p>
           <a:p/>
@@ -2539,7 +2539,7 @@
           </a:p>
           <a:p>
             <a:r>
-              <a:t>"Our limitations. First and most important, we built this system and we evaluate it, and the four measures we put in place limit that bias without removing it. Second, one company in one industry, and a single session of twenty to thirty minutes per respondent — enough to judge usability, not enough to judge reliability over time, which is why we report reliability as experienced within a single session and back the longer-term question with automated testing instead. Third, shortfalls we name ourselves: the paired comparison was capped at twenty against a planned forty, every item is closed so an unanticipated problem could not be reported, and Instrument C recorded no demographics so we cannot show our before and after groups resemble each other. And finally, we measured the quality of the system, not whether it gets anybody hired."</a:t>
+              <a:t>"Our limitations. First and most important, this study is not independent of us. None of us rated the system — every rating came from an external respondent — but we wrote the instruments and recruited the people who answered them, and they knew whose system it was. The four measures we put in place limit that bias without removing it. Second, one company in one industry, and a single session of twenty to thirty minutes per respondent — enough to judge usability, not enough to judge reliability over time, which is why we report reliability as experienced within a single session and back the longer-term question with automated testing instead. Third, shortfalls we name ourselves: the paired comparison was capped at twenty against a planned forty, every item is closed so an unanticipated problem could not be reported, and Instrument C recorded no demographics so we cannot show our before and after groups resemble each other. And finally, we measured the quality of the system, not whether it gets anybody hired."</a:t>
             </a:r>
           </a:p>
           <a:p/>
@@ -2583,7 +2583,7 @@
           </a:p>
           <a:p>
             <a:r>
-              <a:t>"That we evaluate our own system. Everything else has a bound we can state; that one has a bound we can only reduce. We limit it with confidential responses, no researcher present, an invitation welcoming low ratings, and a scale published in advance. It limits the bias. It does not remove it."</a:t>
+              <a:t>"That the study is not independent of the people who built the system. Not that we rated it — every rating came from an outside respondent — but that we wrote the instruments and recruited the people who answered them. Everything else has a bound we can state; that one has a bound we can only reduce. We limit it with confidential responses, no researcher present, an invitation welcoming low ratings, and a scale published in advance. It limits the bias. It does not remove it."</a:t>
             </a:r>
           </a:p>
           <a:p/>
@@ -9358,7 +9358,7 @@
                 </a:solidFill>
                 <a:latin typeface="Calibri"/>
               </a:rPr>
-              <a:t>Including the threat we cannot remove</a:t>
+              <a:t>Including the one threat we can only reduce</a:t>
             </a:r>
           </a:p>
         </p:txBody>
@@ -9505,7 +9505,7 @@
                 </a:solidFill>
                 <a:latin typeface="Calibri"/>
               </a:rPr>
-              <a:t>The threat we cannot remove</a:t>
+              <a:t>The one threat we can only reduce</a:t>
             </a:r>
           </a:p>
           <a:p>
@@ -9521,7 +9521,7 @@
                 </a:solidFill>
                 <a:latin typeface="Calibri"/>
               </a:rPr>
-              <a:t>We built the system and we evaluate it. Four measures limit it: confidential responses · no researcher present while anyone answers · an invitation stating that critical ratings are as useful as favourable ones · an interpretation scale published before data collection.</a:t>
+              <a:t>Every rating came from an external respondent — no researcher rated our own system. What remains is that we wrote the instruments and recruited the respondents, who knew whose system they were rating. Four measures limit it: confidential responses · no researcher present while anyone answers · an invitation stating that critical ratings are as useful as favourable ones · an interpretation scale published before data collection.</a:t>
             </a:r>
           </a:p>
           <a:p>
@@ -14240,7 +14240,7 @@
                 </a:solidFill>
                 <a:latin typeface="Calibri"/>
               </a:rPr>
-              <a:t>Self-evaluation</a:t>
+              <a:t>Rated by outsiders, but not an independent study</a:t>
             </a:r>
           </a:p>
           <a:p>
@@ -14256,7 +14256,7 @@
                 </a:solidFill>
                 <a:latin typeface="Calibri"/>
               </a:rPr>
-              <a:t>We built the system and we evaluate it. Four measures limit that bias. They do not remove it.</a:t>
+              <a:t>Every rating came from an external respondent — none of us rated our own system. What remains is that we wrote the instruments and recruited the respondents, who knew whose system they were rating. Four measures limit that. They do not remove it.</a:t>
             </a:r>
           </a:p>
           <a:p>

</xml_diff>